<commit_message>
Update presentation with new features: search, toasts, keyboard shortcuts
- Overview: Add toast notifications and keyboard shortcuts to Analytics
- Architecture: Update endpoint count from 32+ to 40+
- Dashboard: Add Top 3 Opportunities and last-updated timestamp
- Markets: Add search, sort, and filter controls
- Performance: Add dual CSV export (live + paper)
- Getting Started: Update endpoint count

Co-Authored-By: Claude Opus 4.6 <noreply@anthropic.com>
</commit_message>
<xml_diff>
--- a/PredictionBot_Presentation.pptx
+++ b/PredictionBot_Presentation.pptx
@@ -8235,7 +8235,7 @@
             </a:r>
             <a:br/>
             <a:r>
-              <a:t>Runs FastAPI on port 8000 with 32+ REST endpoints</a:t>
+              <a:t>Runs FastAPI on port 8000 with 40+ REST endpoints</a:t>
             </a:r>
             <a:br/>
             <a:r>
@@ -9527,7 +9527,7 @@
             </a:r>
             <a:br/>
             <a:r>
-              <a:t>CSV export &amp; trade notes</a:t>
+              <a:t>CSV export, toast notifications, keyboard shortcuts</a:t>
             </a:r>
           </a:p>
         </p:txBody>
@@ -10085,7 +10085,7 @@
               </a:defRPr>
             </a:pPr>
             <a:r>
-              <a:t>  FastAPI (32+ REST endpoints)</a:t>
+              <a:t>  FastAPI (40+ REST endpoints)</a:t>
             </a:r>
           </a:p>
         </p:txBody>
@@ -12943,7 +12943,7 @@
               </a:defRPr>
             </a:pPr>
             <a:r>
-              <a:t>Scan Summary</a:t>
+              <a:t>Top 3 Opportunities + Scan Summary</a:t>
             </a:r>
           </a:p>
         </p:txBody>
@@ -12979,7 +12979,7 @@
               </a:defRPr>
             </a:pPr>
             <a:r>
-              <a:t>Quick-scan button triggers RF market scan. Shows count of signals found, last scan timestamp, and entry/exit signal summary.</a:t>
+              <a:t>Top 3 market opportunities with earning potential calculator ($10-$500 bet selector). Auto-refreshes every 30s. Last-updated timestamp shows data freshness. Scan summary with signal counts.</a:t>
             </a:r>
           </a:p>
         </p:txBody>
@@ -15178,7 +15178,7 @@
               </a:defRPr>
             </a:pPr>
             <a:r>
-              <a:t>Browse and analyze Kalshi markets</a:t>
+              <a:t>Search, sort, filter, and analyze Kalshi markets</a:t>
             </a:r>
           </a:p>
         </p:txBody>
@@ -15260,7 +15260,7 @@
               </a:defRPr>
             </a:pPr>
             <a:r>
-              <a:t>MARKETS TABLE</a:t>
+              <a:t>MARKETS TABLE (with search, sort by 6 criteria, status filter pills)</a:t>
             </a:r>
           </a:p>
         </p:txBody>
@@ -17401,7 +17401,7 @@
             </a:r>
             <a:br/>
             <a:r>
-              <a:t>Editable notes per trade  |  CSV export  |  Sharpe Ratio Guide (&lt; 1 poor, 1-2 good, &gt; 2 excellent)</a:t>
+              <a:t>Editable notes per trade  |  CSV export (live + paper)  |  Sharpe Ratio Guide (&lt; 1 poor, 1-2 good, &gt; 2 excellent)</a:t>
             </a:r>
           </a:p>
         </p:txBody>

</xml_diff>

<commit_message>
Iteration 2: Thread safety, validation, inline confirmations, non-blocking scans
- Add asyncio.Lock for cache writes and batch log flushes in auto-scan job
- Replace browser confirm() with inline confirm/cancel UI for auto-trade toggle
- Add Pydantic Field validation bounds on all ConfigUpdate and BacktestRequest fields
- Run Kalshi API calls and ML inference in asyncio.to_thread to avoid blocking event loop
- Make CORS origins configurable via CORS_ORIGINS env var
- Add AbortController 30s timeout to all frontend API calls
- Add search and sort controls to Signals component
- Safe env var parsing with fallback defaults in config.py
- Wrap all Supabase writes in try/except to prevent background job crashes
- Update README with new features and architectural improvements
- Update PowerPoint presentation

Co-Authored-By: Claude Opus 4.6 <noreply@anthropic.com>
</commit_message>
<xml_diff>
--- a/PredictionBot_Presentation.pptx
+++ b/PredictionBot_Presentation.pptx
@@ -5245,7 +5245,7 @@
               </a:defRPr>
             </a:pPr>
             <a:r>
-              <a:t>Auto-Scan toggle (paper trading loop) + Auto-Trade toggle (live Kalshi orders). Configurable scan interval. Scan result log.</a:t>
+              <a:t>Auto-Scan toggle (paper trading loop) + Auto-Trade toggle with inline confirmation (live Kalshi orders). Configurable scan interval. Scan result log.</a:t>
             </a:r>
           </a:p>
         </p:txBody>
@@ -9527,7 +9527,7 @@
             </a:r>
             <a:br/>
             <a:r>
-              <a:t>CSV export, toast notifications, keyboard shortcuts</a:t>
+              <a:t>CSV export, toast notifications, keyboard shortcuts, accessibility labels, loading skeletons, inline confirmations</a:t>
             </a:r>
           </a:p>
         </p:txBody>
@@ -10193,7 +10193,7 @@
               </a:defRPr>
             </a:pPr>
             <a:r>
-              <a:t>  Pydantic config + risk manager</a:t>
+              <a:t>  Pydantic validation + risk manager</a:t>
             </a:r>
           </a:p>
         </p:txBody>

</xml_diff>